<commit_message>
adding Snakemake resources bullet list to .md file
</commit_message>
<xml_diff>
--- a/Day3-Shotgun/presentations/2026_Aug_OHMCKickstart_Snakemake.pptx
+++ b/Day3-Shotgun/presentations/2026_Aug_OHMCKickstart_Snakemake.pptx
@@ -23,7 +23,7 @@
     <p:sldId id="268" r:id="rId14"/>
     <p:sldId id="269" r:id="rId15"/>
     <p:sldId id="270" r:id="rId16"/>
-    <p:sldId id="271" r:id="rId17"/>
+    <p:sldId id="273" r:id="rId17"/>
     <p:sldId id="272" r:id="rId18"/>
   </p:sldIdLst>
   <p:sldSz cx="12192000" cy="6858000"/>
@@ -126,6 +126,50 @@
     </p:ext>
   </p:extLst>
 </p:presentation>
+</file>
+
+<file path=ppt/revisionInfo.xml><?xml version="1.0" encoding="utf-8"?>
+<p1510:revInfo xmlns:a="http://schemas.openxmlformats.org/drawingml/2006/main" xmlns:r="http://schemas.openxmlformats.org/officeDocument/2006/relationships" xmlns:p1510="http://schemas.microsoft.com/office/powerpoint/2015/10/main">
+  <p1510:revLst>
+    <p1510:client id="{622324D4-35AC-DD41-BD51-BC75C6AA8687}" v="3" dt="2026-08-07T14:14:42.071"/>
+  </p1510:revLst>
+</p1510:revInfo>
+</file>
+
+<file path=ppt/changesInfos/changesInfo1.xml><?xml version="1.0" encoding="utf-8"?>
+<pc:chgInfo xmlns:a="http://schemas.openxmlformats.org/drawingml/2006/main" xmlns:r="http://schemas.openxmlformats.org/officeDocument/2006/relationships" xmlns:ac="http://schemas.microsoft.com/office/drawing/2013/main/command" xmlns:pc="http://schemas.microsoft.com/office/powerpoint/2013/main/command">
+  <pc:docChgLst>
+    <pc:chgData name="Grembi, Jessica A" userId="56cd76cd-fca5-4749-a76d-c08c17a47ed2" providerId="ADAL" clId="{56DD2E02-A218-5FA5-B1D3-E2C5781AC4D5}"/>
+    <pc:docChg chg="addSld delSld modSld">
+      <pc:chgData name="Grembi, Jessica A" userId="56cd76cd-fca5-4749-a76d-c08c17a47ed2" providerId="ADAL" clId="{56DD2E02-A218-5FA5-B1D3-E2C5781AC4D5}" dt="2026-08-07T14:14:59.705" v="2" actId="2696"/>
+      <pc:docMkLst>
+        <pc:docMk/>
+      </pc:docMkLst>
+      <pc:sldChg chg="modSp del">
+        <pc:chgData name="Grembi, Jessica A" userId="56cd76cd-fca5-4749-a76d-c08c17a47ed2" providerId="ADAL" clId="{56DD2E02-A218-5FA5-B1D3-E2C5781AC4D5}" dt="2026-08-07T14:14:59.705" v="2" actId="2696"/>
+        <pc:sldMkLst>
+          <pc:docMk/>
+          <pc:sldMk cId="0" sldId="271"/>
+        </pc:sldMkLst>
+        <pc:spChg chg="mod">
+          <ac:chgData name="Grembi, Jessica A" userId="56cd76cd-fca5-4749-a76d-c08c17a47ed2" providerId="ADAL" clId="{56DD2E02-A218-5FA5-B1D3-E2C5781AC4D5}" dt="2026-08-07T13:00:06.089" v="0"/>
+          <ac:spMkLst>
+            <pc:docMk/>
+            <pc:sldMk cId="0" sldId="271"/>
+            <ac:spMk id="26" creationId="{00000000-0000-0000-0000-000000000000}"/>
+          </ac:spMkLst>
+        </pc:spChg>
+      </pc:sldChg>
+      <pc:sldChg chg="add setBg">
+        <pc:chgData name="Grembi, Jessica A" userId="56cd76cd-fca5-4749-a76d-c08c17a47ed2" providerId="ADAL" clId="{56DD2E02-A218-5FA5-B1D3-E2C5781AC4D5}" dt="2026-08-07T14:14:42.069" v="1"/>
+        <pc:sldMkLst>
+          <pc:docMk/>
+          <pc:sldMk cId="0" sldId="273"/>
+        </pc:sldMkLst>
+      </pc:sldChg>
+    </pc:docChg>
+  </pc:docChgLst>
+</pc:chgInfo>
 </file>
 
 <file path=ppt/notesMasters/notesMaster1.xml><?xml version="1.0" encoding="utf-8"?>
@@ -8912,15 +8956,7 @@
 
 <file path=ppt/slides/slide16.xml><?xml version="1.0" encoding="utf-8"?>
 <p:sld xmlns:a="http://schemas.openxmlformats.org/drawingml/2006/main" xmlns:r="http://schemas.openxmlformats.org/officeDocument/2006/relationships" xmlns:p="http://schemas.openxmlformats.org/presentationml/2006/main">
-  <p:cSld name="Slide 16">
-    <p:bg>
-      <p:bgPr>
-        <a:solidFill>
-          <a:srgbClr val="FFFFFF"/>
-        </a:solidFill>
-        <a:effectLst/>
-      </p:bgPr>
-    </p:bg>
+  <p:cSld>
     <p:spTree>
       <p:nvGrpSpPr>
         <p:cNvPr id="1" name=""/>
@@ -9958,7 +9994,7 @@
                 <a:ea typeface="Calibri" pitchFamily="34" charset="-122"/>
                 <a:cs typeface="Calibri" pitchFamily="34" charset="-120"/>
               </a:rPr>
-              <a:t>Snakemake cheat sheet</a:t>
+              <a:t>Snakemake terminology guide</a:t>
             </a:r>
             <a:endParaRPr lang="en-US" sz="1350" dirty="0"/>
           </a:p>
@@ -10000,32 +10036,10 @@
                 <a:ea typeface="Courier New" pitchFamily="34" charset="-122"/>
                 <a:cs typeface="Courier New" pitchFamily="34" charset="-120"/>
               </a:rPr>
-              <a:t>gist.github.com/npicciani</a:t>
+              <a:t>medium.com/@mandhri.abeysooriya/</a:t>
             </a:r>
             <a:endParaRPr lang="en-US" sz="900" dirty="0"/>
           </a:p>
-        </p:txBody>
-      </p:sp>
-      <p:sp>
-        <p:nvSpPr>
-          <p:cNvPr id="33" name="Text 26"/>
-          <p:cNvSpPr/>
-          <p:nvPr/>
-        </p:nvSpPr>
-        <p:spPr>
-          <a:xfrm>
-            <a:off x="4606442" y="5257800"/>
-            <a:ext cx="2978810" cy="384048"/>
-          </a:xfrm>
-          <a:prstGeom prst="rect">
-            <a:avLst/>
-          </a:prstGeom>
-          <a:noFill/>
-          <a:ln/>
-        </p:spPr>
-        <p:txBody>
-          <a:bodyPr wrap="square" lIns="0" tIns="0" rIns="0" bIns="0" rtlCol="0" anchor="ctr"/>
-          <a:lstStyle/>
           <a:p>
             <a:pPr marL="0" indent="0">
               <a:lnSpc>
@@ -10034,6 +10048,48 @@
               <a:buNone/>
             </a:pPr>
             <a:r>
+              <a:rPr lang="en-US" sz="900" dirty="0">
+                <a:solidFill>
+                  <a:srgbClr val="039475"/>
+                </a:solidFill>
+                <a:latin typeface="Courier New" pitchFamily="34" charset="0"/>
+                <a:ea typeface="Courier New" pitchFamily="34" charset="-122"/>
+                <a:cs typeface="Courier New" pitchFamily="34" charset="-120"/>
+              </a:rPr>
+              <a:t>snakemake-terms-you-will-meet-cheat-sheet</a:t>
+            </a:r>
+            <a:endParaRPr lang="en-US" sz="900" dirty="0"/>
+          </a:p>
+        </p:txBody>
+      </p:sp>
+      <p:sp>
+        <p:nvSpPr>
+          <p:cNvPr id="33" name="Text 26"/>
+          <p:cNvSpPr/>
+          <p:nvPr/>
+        </p:nvSpPr>
+        <p:spPr>
+          <a:xfrm>
+            <a:off x="4606442" y="5257800"/>
+            <a:ext cx="2978810" cy="384048"/>
+          </a:xfrm>
+          <a:prstGeom prst="rect">
+            <a:avLst/>
+          </a:prstGeom>
+          <a:noFill/>
+          <a:ln/>
+        </p:spPr>
+        <p:txBody>
+          <a:bodyPr wrap="square" lIns="0" tIns="0" rIns="0" bIns="0" rtlCol="0" anchor="ctr"/>
+          <a:lstStyle/>
+          <a:p>
+            <a:pPr marL="0" indent="0">
+              <a:lnSpc>
+                <a:spcPct val="110000"/>
+              </a:lnSpc>
+              <a:buNone/>
+            </a:pPr>
+            <a:r>
               <a:rPr lang="en-US" sz="1000" dirty="0">
                 <a:solidFill>
                   <a:srgbClr val="5C6B66"/>
@@ -10042,7 +10098,7 @@
                 <a:ea typeface="Calibri" pitchFamily="34" charset="-122"/>
                 <a:cs typeface="Calibri" pitchFamily="34" charset="-120"/>
               </a:rPr>
-              <a:t>quick reference &amp; the project structure from this talk</a:t>
+              <a:t>plain-English definitions of every term you'll encounter, with examples</a:t>
             </a:r>
             <a:endParaRPr lang="en-US" sz="1000" dirty="0"/>
           </a:p>
@@ -18818,4 +18874,10 @@
     </a:ext>
   </a:extLst>
 </a:theme>
+</file>
+
+<file path=docMetadata/LabelInfo.xml><?xml version="1.0" encoding="utf-8"?>
+<clbl:labelList xmlns:clbl="http://schemas.microsoft.com/office/2020/mipLabelMetadata">
+  <clbl:label id="{7cf48d45-3ddb-4389-a9c1-c115526eb52e}" enabled="0" method="" siteId="{7cf48d45-3ddb-4389-a9c1-c115526eb52e}" removed="1"/>
+</clbl:labelList>
 </file>
</xml_diff>